<commit_message>
收工：QuantImmuBench deepHLApan indel 补满(9mer+8-11mer 101→130) + 30工具隐藏问题审计 + Caveman 彻底移除
QuantImmuBench (LOG Entry 51/52/53):
- 图1 数值三方对账 PASS + DeepNetBim「覆盖失败」→「max-pool 退化」标签修正 + MHCnuggets CI 修
- deepHLApan 根因: context-free 单肽被 MT-WT 配对输入误滤 28 indel+1 SNV;
  docker context-free 补跑 → 9mer 101→130 入主榜(rho 0.101→0.052), 8-11mer 同步补满
- 全30工具隐藏问题审计(verifier+analyst): 无第二例误归组; 8-11mer 新发现 3 工具口径过度声称 + indel-9mer-only
- 重出 fig1(9mer/8-11mer)+对比图+覆盖矩阵; ppt progress rev5 + 8-11mer supplement rev1

Caveman 彻底移除(用户要求): 用户/项目 settings hooks+plugin+marketplace; CLAUDE.md; 13 agent spec(保真红线保留); 归档

Co-Authored-By: Claude Opus 4.8 <noreply@anthropic.com>
</commit_message>
<xml_diff>
--- a/project/meeting/QuantImmuBench/QuantImmuBench_8to11mer_supplement_2026-07-03.pptx
+++ b/project/meeting/QuantImmuBench/QuantImmuBench_8to11mer_supplement_2026-07-03.pptx
@@ -4464,30 +4464,6 @@
           </a:p>
         </p:txBody>
       </p:sp>
-      <p:pic>
-        <p:nvPicPr>
-          <p:cNvPr id="4" name="Picture 3" descr="fig1_spearman_30tools_8to11mer_effN8.png"/>
-          <p:cNvPicPr>
-            <a:picLocks noChangeAspect="1"/>
-          </p:cNvPicPr>
-          <p:nvPr/>
-        </p:nvPicPr>
-        <p:blipFill>
-          <a:blip r:embed="rId2"/>
-          <a:stretch>
-            <a:fillRect/>
-          </a:stretch>
-        </p:blipFill>
-        <p:spPr>
-          <a:xfrm>
-            <a:off x="757263" y="960120"/>
-            <a:ext cx="5617793" cy="5669280"/>
-          </a:xfrm>
-          <a:prstGeom prst="rect">
-            <a:avLst/>
-          </a:prstGeom>
-        </p:spPr>
-      </p:pic>
       <p:sp>
         <p:nvSpPr>
           <p:cNvPr id="5" name="Rectangle 4"/>
@@ -4652,6 +4628,30 @@
           </a:p>
         </p:txBody>
       </p:sp>
+      <p:pic>
+        <p:nvPicPr>
+          <p:cNvPr id="7" name="Picture 6" descr="fig1_spearman_30tools_8to11mer_effN8.png"/>
+          <p:cNvPicPr>
+            <a:picLocks noChangeAspect="1"/>
+          </p:cNvPicPr>
+          <p:nvPr/>
+        </p:nvPicPr>
+        <p:blipFill>
+          <a:blip r:embed="rId3"/>
+          <a:stretch>
+            <a:fillRect/>
+          </a:stretch>
+        </p:blipFill>
+        <p:spPr>
+          <a:xfrm>
+            <a:off x="757263" y="960120"/>
+            <a:ext cx="5617793" cy="5669279"/>
+          </a:xfrm>
+          <a:prstGeom prst="rect">
+            <a:avLst/>
+          </a:prstGeom>
+        </p:spPr>
+      </p:pic>
     </p:spTree>
   </p:cSld>
   <p:clrMapOvr>
@@ -4764,30 +4764,6 @@
           </a:p>
         </p:txBody>
       </p:sp>
-      <p:pic>
-        <p:nvPicPr>
-          <p:cNvPr id="4" name="Picture 3" descr="fig_9mer_vs_8to11mer_spearman.png"/>
-          <p:cNvPicPr>
-            <a:picLocks noChangeAspect="1"/>
-          </p:cNvPicPr>
-          <p:nvPr/>
-        </p:nvPicPr>
-        <p:blipFill>
-          <a:blip r:embed="rId2"/>
-          <a:stretch>
-            <a:fillRect/>
-          </a:stretch>
-        </p:blipFill>
-        <p:spPr>
-          <a:xfrm>
-            <a:off x="1147946" y="960120"/>
-            <a:ext cx="3556267" cy="5669280"/>
-          </a:xfrm>
-          <a:prstGeom prst="rect">
-            <a:avLst/>
-          </a:prstGeom>
-        </p:spPr>
-      </p:pic>
       <p:sp>
         <p:nvSpPr>
           <p:cNvPr id="5" name="Rectangle 4"/>
@@ -4997,7 +4973,7 @@
                 </a:solidFill>
                 <a:latin typeface="Microsoft YaHei"/>
               </a:rPr>
-              <a:t>83%</a:t>
+              <a:t>86%</a:t>
             </a:r>
           </a:p>
         </p:txBody>
@@ -5039,7 +5015,7 @@
                 </a:solidFill>
                 <a:latin typeface="Microsoft YaHei"/>
               </a:rPr>
-              <a:t>24/29 工具 9mer &gt; 8–11mer</a:t>
+              <a:t>24/28 工具 9mer &gt; 8–11mer</a:t>
             </a:r>
           </a:p>
         </p:txBody>
@@ -5146,7 +5122,7 @@
                 </a:solidFill>
                 <a:latin typeface="Microsoft YaHei"/>
               </a:rPr>
-              <a:t>• 均值 rho：9mer = 0.189  vs  8–11mer = 0.122。</a:t>
+              <a:t>• 均值 rho：9mer = 0.193  vs  8–11mer = 0.124（仅两口径都适用的 28 工具）。</a:t>
             </a:r>
           </a:p>
           <a:p>
@@ -5203,11 +5179,35 @@
                 </a:solidFill>
                 <a:latin typeface="Microsoft YaHei"/>
               </a:rPr>
-              <a:t>• 注：MHCseqNet(0.246→−0.227)、Seq2Neo(0.072→−0.084) 在可变窗大跌，是真实结果非 bug。</a:t>
-            </a:r>
-          </a:p>
-        </p:txBody>
-      </p:sp>
+              <a:t>• 注：MHCseqNet(0.246→−0.227) 在可变窗翻负是真实结果非 bug —— 74% 肽的 max 被非 9mer 窗抢走，而其非 9mer 打分与免疫原性反相关，把排序打反；对比图已剔 DeepNetBim/NeoaPred（硬 9mer，8-11 值≡9mer 的假对比）。</a:t>
+            </a:r>
+          </a:p>
+        </p:txBody>
+      </p:sp>
+      <p:pic>
+        <p:nvPicPr>
+          <p:cNvPr id="13" name="Picture 12" descr="fig_9mer_vs_8to11mer_spearman.png"/>
+          <p:cNvPicPr>
+            <a:picLocks noChangeAspect="1"/>
+          </p:cNvPicPr>
+          <p:nvPr/>
+        </p:nvPicPr>
+        <p:blipFill>
+          <a:blip r:embed="rId4"/>
+          <a:stretch>
+            <a:fillRect/>
+          </a:stretch>
+        </p:blipFill>
+        <p:spPr>
+          <a:xfrm>
+            <a:off x="1147946" y="2074847"/>
+            <a:ext cx="3556267" cy="3439825"/>
+          </a:xfrm>
+          <a:prstGeom prst="rect">
+            <a:avLst/>
+          </a:prstGeom>
+        </p:spPr>
+      </p:pic>
     </p:spTree>
   </p:cSld>
   <p:clrMapOvr>
@@ -5320,30 +5320,6 @@
           </a:p>
         </p:txBody>
       </p:sp>
-      <p:pic>
-        <p:nvPicPr>
-          <p:cNvPr id="4" name="Picture 3" descr="fig_8to11mer_coverage.png"/>
-          <p:cNvPicPr>
-            <a:picLocks noChangeAspect="1"/>
-          </p:cNvPicPr>
-          <p:nvPr/>
-        </p:nvPicPr>
-        <p:blipFill>
-          <a:blip r:embed="rId2"/>
-          <a:stretch>
-            <a:fillRect/>
-          </a:stretch>
-        </p:blipFill>
-        <p:spPr>
-          <a:xfrm>
-            <a:off x="1138287" y="960120"/>
-            <a:ext cx="3575585" cy="5669280"/>
-          </a:xfrm>
-          <a:prstGeom prst="rect">
-            <a:avLst/>
-          </a:prstGeom>
-        </p:spPr>
-      </p:pic>
       <p:sp>
         <p:nvSpPr>
           <p:cNvPr id="5" name="Rectangle 4"/>
@@ -5655,6 +5631,30 @@
           </a:p>
         </p:txBody>
       </p:sp>
+      <p:pic>
+        <p:nvPicPr>
+          <p:cNvPr id="10" name="Picture 9" descr="fig_8to11mer_coverage.png"/>
+          <p:cNvPicPr>
+            <a:picLocks noChangeAspect="1"/>
+          </p:cNvPicPr>
+          <p:nvPr/>
+        </p:nvPicPr>
+        <p:blipFill>
+          <a:blip r:embed="rId3"/>
+          <a:stretch>
+            <a:fillRect/>
+          </a:stretch>
+        </p:blipFill>
+        <p:spPr>
+          <a:xfrm>
+            <a:off x="1138287" y="2107837"/>
+            <a:ext cx="3575585" cy="3373845"/>
+          </a:xfrm>
+          <a:prstGeom prst="rect">
+            <a:avLst/>
+          </a:prstGeom>
+        </p:spPr>
+      </p:pic>
     </p:spTree>
   </p:cSld>
   <p:clrMapOvr>
@@ -5874,8 +5874,8 @@
         </p:nvSpPr>
         <p:spPr>
           <a:xfrm>
-            <a:off x="822960" y="4892040"/>
-            <a:ext cx="10561320" cy="1371600"/>
+            <a:off x="822960" y="3246120"/>
+            <a:ext cx="10561320" cy="3474720"/>
           </a:xfrm>
           <a:prstGeom prst="rect">
             <a:avLst/>
@@ -5918,8 +5918,8 @@
         </p:nvSpPr>
         <p:spPr>
           <a:xfrm>
-            <a:off x="1051560" y="5029200"/>
-            <a:ext cx="10149840" cy="1188720"/>
+            <a:off x="1051560" y="3383280"/>
+            <a:ext cx="10149840" cy="3246120"/>
           </a:xfrm>
           <a:prstGeom prst="rect">
             <a:avLst/>
@@ -5986,6 +5986,41 @@
                 <a:latin typeface="Microsoft YaHei"/>
               </a:rPr>
               <a:t>• 产物：pooled_clean_8to11mer.csv · fig1_8to11mer · fig_9mer_vs_8to11mer · fig_8to11mer_coverage · 04_LOG Entry 49</a:t>
+            </a:r>
+          </a:p>
+          <a:p>
+            <a:pPr>
+              <a:spcBef>
+                <a:spcPts val="800"/>
+              </a:spcBef>
+            </a:pPr>
+            <a:r>
+              <a:rPr sz="1400" b="1">
+                <a:solidFill>
+                  <a:srgbClr val="FFC107"/>
+                </a:solidFill>
+              </a:rPr>
+              <a:t>📝 写作待核（投稿前 tex 措辞，勿臆想 · 联网核实 2026-07-04）</a:t>
+            </a:r>
+          </a:p>
+          <a:p>
+            <a:r>
+              <a:rPr sz="1250" b="0">
+                <a:solidFill>
+                  <a:srgbClr val="CADCFC"/>
+                </a:solidFill>
+              </a:rPr>
+              <a:t>• 9mer≈44% 精确四分位值 = 二手检索合成(相加略&gt;100) → 写死前人工核 Trolle 2016 J Immunol 原表 / IEDB 直查；当前仅「9mer 单一最丰富」为硬证</a:t>
+            </a:r>
+          </a:p>
+          <a:p>
+            <a:r>
+              <a:rPr sz="1250" b="0">
+                <a:solidFill>
+                  <a:srgbClr val="CADCFC"/>
+                </a:solidFill>
+              </a:rPr>
+              <a:t>• 「9mer-only 排序优于 8–11 可变窗」两轮检索无直接先例也无反例 → 本 24/29 为该口径首个系统证据，tex 须标「据我们所知无直接先例」，禁 claim 有文献支撑（对 BiB 反是加分贡献点）</a:t>
             </a:r>
           </a:p>
         </p:txBody>

</xml_diff>